<commit_message>
Add slides 14-15: MCP Servers and AI Agents (matching deck theme & logo)
- Slide 14 'MCP Servers: Connecting Claude to Enterprise Systems': hub-and-spoke
  diagram (Claude core + SharePoint, Jira, Salesforce, SQL, APIs, Healthcare KB),
  Without/With MCP cards, navy callout banner, speaker notes
- Slide 15 'AI Agents: Moving Beyond Questions & Answers': Goal->Plan->Tools->
  Execute->Validate->Outcome pipeline, agent traits strip, Healthcare prior-auth
  and Business market-research example cards, speaker notes
- Reuses real theme colors (1565C0/00897B/5E35B1), Aptos/Calibri fonts, Innova
  logo (image11.png), footer, and slideLayout18
- Removed earlier standalone attempt files
</commit_message>
<xml_diff>
--- a/AI & Claude use case.pptx
+++ b/AI & Claude use case.pptx
@@ -21,6 +21,8 @@
     <p:sldId id="415" r:id="rId12"/>
     <p:sldId id="414" r:id="rId13"/>
     <p:sldId id="413" r:id="rId14"/>
+    <p:sldId id="420" r:id="rId22"/>
+    <p:sldId id="421" r:id="rId23"/>
   </p:sldIdLst>
   <p:sldSz cx="12192000" cy="6858000"/>
   <p:notesSz cx="6858000" cy="9144000"/>
@@ -951,6 +953,118 @@
         <p14:creationId xmlns:p14="http://schemas.microsoft.com/office/powerpoint/2010/main" val="1356438976"/>
       </p:ext>
     </p:extLst>
+  </p:cSld>
+  <p:clrMapOvr>
+    <a:masterClrMapping/>
+  </p:clrMapOvr>
+</p:notes>
+</file>
+
+<file path=ppt/notesSlides/notesSlide14.xml><?xml version="1.0" encoding="utf-8"?>
+<p:notes xmlns:a="http://schemas.openxmlformats.org/drawingml/2006/main" xmlns:r="http://schemas.openxmlformats.org/officeDocument/2006/relationships" xmlns:p="http://schemas.openxmlformats.org/presentationml/2006/main">
+  <p:cSld>
+    <p:spTree>
+      <p:nvGrpSpPr>
+        <p:cNvPr id="1" name=""/>
+        <p:cNvGrpSpPr/>
+        <p:nvPr/>
+      </p:nvGrpSpPr>
+      <p:grpSpPr>
+        <a:xfrm>
+          <a:off x="0" y="0"/>
+          <a:ext cx="0" cy="0"/>
+          <a:chOff x="0" y="0"/>
+          <a:chExt cx="0" cy="0"/>
+        </a:xfrm>
+      </p:grpSpPr>
+      <p:sp>
+        <p:nvSpPr>
+          <p:cNvPr id="2" name="Notes Placeholder 1"/>
+          <p:cNvSpPr>
+            <a:spLocks noGrp="1"/>
+          </p:cNvSpPr>
+          <p:nvPr>
+            <p:ph type="body" idx="1"/>
+          </p:nvPr>
+        </p:nvSpPr>
+        <p:spPr/>
+        <p:txBody>
+          <a:bodyPr/>
+          <a:lstStyle/>
+          <a:p>
+            <a:pPr marL="0" indent="0" algn="l">
+              <a:buNone/>
+            </a:pPr>
+            <a:r>
+              <a:rPr lang="en-US" sz="1200" b="0" i="0" dirty="0">
+                <a:solidFill>
+                  <a:srgbClr val="000000"/>
+                </a:solidFill>
+                <a:latin typeface="Calibri" pitchFamily="34" charset="0"/>
+                <a:cs typeface="Calibri" pitchFamily="34" charset="0"/>
+              </a:rPr>
+              <a:t>MCP acts as a secure bridge between Claude and business systems, letting AI work with real organizational data instead of only manually pasted text. Keep it conceptual for beginners — emphasize secure, governed access to tools like SharePoint, Jira, Salesforce, SQL databases and healthcare knowledge bases.</a:t>
+            </a:r>
+          </a:p>
+        </p:txBody>
+      </p:sp>
+    </p:spTree>
+  </p:cSld>
+  <p:clrMapOvr>
+    <a:masterClrMapping/>
+  </p:clrMapOvr>
+</p:notes>
+</file>
+
+<file path=ppt/notesSlides/notesSlide15.xml><?xml version="1.0" encoding="utf-8"?>
+<p:notes xmlns:a="http://schemas.openxmlformats.org/drawingml/2006/main" xmlns:r="http://schemas.openxmlformats.org/officeDocument/2006/relationships" xmlns:p="http://schemas.openxmlformats.org/presentationml/2006/main">
+  <p:cSld>
+    <p:spTree>
+      <p:nvGrpSpPr>
+        <p:cNvPr id="1" name=""/>
+        <p:cNvGrpSpPr/>
+        <p:nvPr/>
+      </p:nvGrpSpPr>
+      <p:grpSpPr>
+        <a:xfrm>
+          <a:off x="0" y="0"/>
+          <a:ext cx="0" cy="0"/>
+          <a:chOff x="0" y="0"/>
+          <a:chExt cx="0" cy="0"/>
+        </a:xfrm>
+      </p:grpSpPr>
+      <p:sp>
+        <p:nvSpPr>
+          <p:cNvPr id="2" name="Notes Placeholder 1"/>
+          <p:cNvSpPr>
+            <a:spLocks noGrp="1"/>
+          </p:cNvSpPr>
+          <p:nvPr>
+            <p:ph type="body" idx="1"/>
+          </p:nvPr>
+        </p:nvSpPr>
+        <p:spPr/>
+        <p:txBody>
+          <a:bodyPr/>
+          <a:lstStyle/>
+          <a:p>
+            <a:pPr marL="0" indent="0" algn="l">
+              <a:buNone/>
+            </a:pPr>
+            <a:r>
+              <a:rPr lang="en-US" sz="1200" b="0" i="0" dirty="0">
+                <a:solidFill>
+                  <a:srgbClr val="000000"/>
+                </a:solidFill>
+                <a:latin typeface="Calibri" pitchFamily="34" charset="0"/>
+                <a:cs typeface="Calibri" pitchFamily="34" charset="0"/>
+              </a:rPr>
+              <a:t>Contrast traditional prompt/response AI with agents that plan, use tools, and execute multi-step workflows. Walk through the healthcare prior-authorization example end to end, then the market research example, to show goal-directed, iterative behavior.</a:t>
+            </a:r>
+          </a:p>
+        </p:txBody>
+      </p:sp>
+    </p:spTree>
   </p:cSld>
   <p:clrMapOvr>
     <a:masterClrMapping/>
@@ -17305,6 +17419,2269 @@
 </p:sld>
 </file>
 
+<file path=ppt/slides/slide14.xml><?xml version="1.0" encoding="utf-8"?>
+<p:sld xmlns:a="http://schemas.openxmlformats.org/drawingml/2006/main" xmlns:r="http://schemas.openxmlformats.org/officeDocument/2006/relationships" xmlns:p="http://schemas.openxmlformats.org/presentationml/2006/main">
+  <p:cSld>
+    <p:spTree>
+      <p:nvGrpSpPr>
+        <p:cNvPr id="1" name=""/>
+        <p:cNvGrpSpPr/>
+        <p:nvPr/>
+      </p:nvGrpSpPr>
+      <p:grpSpPr>
+        <a:xfrm>
+          <a:off x="0" y="0"/>
+          <a:ext cx="0" cy="0"/>
+          <a:chOff x="0" y="0"/>
+          <a:chExt cx="0" cy="0"/>
+        </a:xfrm>
+      </p:grpSpPr>
+      <p:sp>
+        <p:nvSpPr>
+          <p:cNvPr id="10" name="Title"/>
+          <p:cNvSpPr/>
+          <p:nvPr/>
+        </p:nvSpPr>
+        <p:spPr>
+          <a:xfrm>
+            <a:off x="313752" y="266276"/>
+            <a:ext cx="9550000" cy="470000"/>
+          </a:xfrm>
+          <a:prstGeom prst="rect">
+            <a:avLst/>
+          </a:prstGeom>
+          <a:noFill/>
+          <a:ln>
+            <a:noFill/>
+          </a:ln>
+        </p:spPr>
+        <p:txBody>
+          <a:bodyPr wrap="square" rtlCol="0" anchor="t" lIns="91440" rIns="91440" tIns="45720" bIns="45720">
+            <a:normAutofit/>
+          </a:bodyPr>
+          <a:lstStyle/>
+          <a:p>
+            <a:pPr marL="0" indent="0" algn="l">
+              <a:buNone/>
+            </a:pPr>
+            <a:r>
+              <a:rPr lang="en-US" sz="2800" b="1" i="0" dirty="0">
+                <a:solidFill>
+                  <a:srgbClr val="1A2B4C"/>
+                </a:solidFill>
+                <a:latin typeface="Aptos" pitchFamily="34" charset="0"/>
+                <a:cs typeface="Aptos" pitchFamily="34" charset="0"/>
+              </a:rPr>
+              <a:t>MCP Servers: Connecting Claude to Enterprise Systems</a:t>
+            </a:r>
+          </a:p>
+        </p:txBody>
+      </p:sp>
+      <p:sp>
+        <p:nvSpPr>
+          <p:cNvPr id="11" name="Subtitle"/>
+          <p:cNvSpPr/>
+          <p:nvPr/>
+        </p:nvSpPr>
+        <p:spPr>
+          <a:xfrm>
+            <a:off x="313752" y="760000"/>
+            <a:ext cx="9269611" cy="470000"/>
+          </a:xfrm>
+          <a:prstGeom prst="rect">
+            <a:avLst/>
+          </a:prstGeom>
+          <a:noFill/>
+          <a:ln>
+            <a:noFill/>
+          </a:ln>
+        </p:spPr>
+        <p:txBody>
+          <a:bodyPr wrap="square" rtlCol="0" anchor="t" lIns="91440" rIns="91440" tIns="45720" bIns="45720">
+            <a:normAutofit/>
+          </a:bodyPr>
+          <a:lstStyle/>
+          <a:p>
+            <a:pPr marL="0" indent="0" algn="l">
+              <a:buNone/>
+            </a:pPr>
+            <a:r>
+              <a:rPr lang="en-US" sz="1300" b="0" i="1" dirty="0">
+                <a:solidFill>
+                  <a:srgbClr val="153D64"/>
+                </a:solidFill>
+                <a:latin typeface="Calibri" pitchFamily="34" charset="0"/>
+                <a:cs typeface="Calibri" pitchFamily="34" charset="0"/>
+              </a:rPr>
+              <a:t>Model Context Protocol (MCP) — an open standard that lets Claude securely connect to enterprise tools, data, and applications, not just pasted text.</a:t>
+            </a:r>
+          </a:p>
+        </p:txBody>
+      </p:sp>
+      <p:sp>
+        <p:nvSpPr>
+          <p:cNvPr id="20" name="cb"/>
+          <p:cNvSpPr/>
+          <p:nvPr/>
+        </p:nvSpPr>
+        <p:spPr>
+          <a:xfrm>
+            <a:off x="313752" y="1430000"/>
+            <a:ext cx="3250000" cy="1180000"/>
+          </a:xfrm>
+          <a:prstGeom prst="roundRect">
+            <a:avLst>
+              <a:gd name="adj" fmla="val 5000"/>
+            </a:avLst>
+          </a:prstGeom>
+          <a:solidFill>
+            <a:srgbClr val="EDE7F6"/>
+          </a:solidFill>
+          <a:ln>
+            <a:noFill/>
+          </a:ln>
+        </p:spPr>
+        <p:txBody>
+          <a:bodyPr wrap="square" rtlCol="0" anchor="t" lIns="91440" rIns="91440" tIns="45720" bIns="45720">
+            <a:normAutofit/>
+          </a:bodyPr>
+          <a:lstStyle/>
+          <a:p>
+            <a:endParaRPr lang="en-US"/>
+          </a:p>
+        </p:txBody>
+      </p:sp>
+      <p:sp>
+        <p:nvSpPr>
+          <p:cNvPr id="21" name="ch"/>
+          <p:cNvSpPr/>
+          <p:nvPr/>
+        </p:nvSpPr>
+        <p:spPr>
+          <a:xfrm>
+            <a:off x="313752" y="1430000"/>
+            <a:ext cx="3250000" cy="470000"/>
+          </a:xfrm>
+          <a:prstGeom prst="roundRect">
+            <a:avLst>
+              <a:gd name="adj" fmla="val 10000"/>
+            </a:avLst>
+          </a:prstGeom>
+          <a:solidFill>
+            <a:srgbClr val="5E35B1"/>
+          </a:solidFill>
+          <a:ln>
+            <a:noFill/>
+          </a:ln>
+        </p:spPr>
+        <p:txBody>
+          <a:bodyPr wrap="square" rtlCol="0" anchor="ctr" lIns="91440" rIns="91440" tIns="45720" bIns="45720">
+            <a:normAutofit/>
+          </a:bodyPr>
+          <a:lstStyle/>
+          <a:p>
+            <a:pPr marL="0" indent="0" algn="l">
+              <a:buNone/>
+            </a:pPr>
+            <a:r>
+              <a:rPr lang="en-US" sz="1200" b="1" i="0" dirty="0">
+                <a:solidFill>
+                  <a:srgbClr val="FFFFFF"/>
+                </a:solidFill>
+                <a:latin typeface="Calibri" pitchFamily="34" charset="0"/>
+                <a:cs typeface="Calibri" pitchFamily="34" charset="0"/>
+              </a:rPr>
+              <a:t>Without MCP</a:t>
+            </a:r>
+          </a:p>
+        </p:txBody>
+      </p:sp>
+      <p:sp>
+        <p:nvSpPr>
+          <p:cNvPr id="22" name="ct"/>
+          <p:cNvSpPr/>
+          <p:nvPr/>
+        </p:nvSpPr>
+        <p:spPr>
+          <a:xfrm>
+            <a:off x="431752" y="1950000"/>
+            <a:ext cx="3014000" cy="600000"/>
+          </a:xfrm>
+          <a:prstGeom prst="rect">
+            <a:avLst/>
+          </a:prstGeom>
+          <a:noFill/>
+          <a:ln>
+            <a:noFill/>
+          </a:ln>
+        </p:spPr>
+        <p:txBody>
+          <a:bodyPr wrap="square" rtlCol="0" anchor="t" lIns="91440" rIns="91440" tIns="45720" bIns="45720">
+            <a:normAutofit/>
+          </a:bodyPr>
+          <a:lstStyle/>
+          <a:p>
+            <a:pPr marL="0" indent="0" algn="l">
+              <a:buNone/>
+            </a:pPr>
+            <a:r>
+              <a:rPr lang="en-US" sz="1050" b="0" i="0" dirty="0">
+                <a:solidFill>
+                  <a:srgbClr val="1A2B4C"/>
+                </a:solidFill>
+                <a:latin typeface="Calibri" pitchFamily="34" charset="0"/>
+                <a:cs typeface="Calibri" pitchFamily="34" charset="0"/>
+              </a:rPr>
+              <a:t>Claude only knows what you paste into the chat — no live access to your systems.</a:t>
+            </a:r>
+          </a:p>
+        </p:txBody>
+      </p:sp>
+      <p:sp>
+        <p:nvSpPr>
+          <p:cNvPr id="23" name="cb"/>
+          <p:cNvSpPr/>
+          <p:nvPr/>
+        </p:nvSpPr>
+        <p:spPr>
+          <a:xfrm>
+            <a:off x="313752" y="2770000"/>
+            <a:ext cx="3250000" cy="2820000"/>
+          </a:xfrm>
+          <a:prstGeom prst="roundRect">
+            <a:avLst>
+              <a:gd name="adj" fmla="val 5000"/>
+            </a:avLst>
+          </a:prstGeom>
+          <a:solidFill>
+            <a:srgbClr val="E0F2F1"/>
+          </a:solidFill>
+          <a:ln>
+            <a:noFill/>
+          </a:ln>
+        </p:spPr>
+        <p:txBody>
+          <a:bodyPr wrap="square" rtlCol="0" anchor="t" lIns="91440" rIns="91440" tIns="45720" bIns="45720">
+            <a:normAutofit/>
+          </a:bodyPr>
+          <a:lstStyle/>
+          <a:p>
+            <a:endParaRPr lang="en-US"/>
+          </a:p>
+        </p:txBody>
+      </p:sp>
+      <p:sp>
+        <p:nvSpPr>
+          <p:cNvPr id="24" name="ch"/>
+          <p:cNvSpPr/>
+          <p:nvPr/>
+        </p:nvSpPr>
+        <p:spPr>
+          <a:xfrm>
+            <a:off x="313752" y="2770000"/>
+            <a:ext cx="3250000" cy="470000"/>
+          </a:xfrm>
+          <a:prstGeom prst="roundRect">
+            <a:avLst>
+              <a:gd name="adj" fmla="val 10000"/>
+            </a:avLst>
+          </a:prstGeom>
+          <a:solidFill>
+            <a:srgbClr val="00897B"/>
+          </a:solidFill>
+          <a:ln>
+            <a:noFill/>
+          </a:ln>
+        </p:spPr>
+        <p:txBody>
+          <a:bodyPr wrap="square" rtlCol="0" anchor="ctr" lIns="91440" rIns="91440" tIns="45720" bIns="45720">
+            <a:normAutofit/>
+          </a:bodyPr>
+          <a:lstStyle/>
+          <a:p>
+            <a:pPr marL="0" indent="0" algn="l">
+              <a:buNone/>
+            </a:pPr>
+            <a:r>
+              <a:rPr lang="en-US" sz="1200" b="1" i="0" dirty="0">
+                <a:solidFill>
+                  <a:srgbClr val="FFFFFF"/>
+                </a:solidFill>
+                <a:latin typeface="Calibri" pitchFamily="34" charset="0"/>
+                <a:cs typeface="Calibri" pitchFamily="34" charset="0"/>
+              </a:rPr>
+              <a:t>With MCP</a:t>
+            </a:r>
+          </a:p>
+        </p:txBody>
+      </p:sp>
+      <p:sp>
+        <p:nvSpPr>
+          <p:cNvPr id="25" name="ct"/>
+          <p:cNvSpPr/>
+          <p:nvPr/>
+        </p:nvSpPr>
+        <p:spPr>
+          <a:xfrm>
+            <a:off x="431752" y="3290000"/>
+            <a:ext cx="3014000" cy="2240000"/>
+          </a:xfrm>
+          <a:prstGeom prst="rect">
+            <a:avLst/>
+          </a:prstGeom>
+          <a:noFill/>
+          <a:ln>
+            <a:noFill/>
+          </a:ln>
+        </p:spPr>
+        <p:txBody>
+          <a:bodyPr wrap="square" rtlCol="0" anchor="t" lIns="91440" rIns="91440" tIns="45720" bIns="45720">
+            <a:normAutofit/>
+          </a:bodyPr>
+          <a:lstStyle/>
+          <a:p>
+            <a:pPr marL="0" indent="0" algn="l">
+              <a:buNone/>
+            </a:pPr>
+            <a:r>
+              <a:rPr lang="en-US" sz="1050" b="1" i="0" dirty="0">
+                <a:solidFill>
+                  <a:srgbClr val="1A2B4C"/>
+                </a:solidFill>
+                <a:latin typeface="Calibri" pitchFamily="34" charset="0"/>
+                <a:cs typeface="Calibri" pitchFamily="34" charset="0"/>
+              </a:rPr>
+              <a:t>With MCP, Claude can:</a:t>
+            </a:r>
+          </a:p>
+          <a:p>
+            <a:pPr marL="0" indent="0" algn="l">
+              <a:spcBef>
+                <a:spcPts val="300"/>
+              </a:spcBef>
+              <a:buNone/>
+            </a:pPr>
+            <a:r>
+              <a:rPr lang="en-US" sz="1050" b="0" i="0" dirty="0">
+                <a:solidFill>
+                  <a:srgbClr val="1A2B4C"/>
+                </a:solidFill>
+                <a:latin typeface="Calibri" pitchFamily="34" charset="0"/>
+                <a:cs typeface="Calibri" pitchFamily="34" charset="0"/>
+              </a:rPr>
+              <a:t>•  Retrieve information</a:t>
+            </a:r>
+          </a:p>
+          <a:p>
+            <a:pPr marL="0" indent="0" algn="l">
+              <a:spcBef>
+                <a:spcPts val="300"/>
+              </a:spcBef>
+              <a:buNone/>
+            </a:pPr>
+            <a:r>
+              <a:rPr lang="en-US" sz="1050" b="0" i="0" dirty="0">
+                <a:solidFill>
+                  <a:srgbClr val="1A2B4C"/>
+                </a:solidFill>
+                <a:latin typeface="Calibri" pitchFamily="34" charset="0"/>
+                <a:cs typeface="Calibri" pitchFamily="34" charset="0"/>
+              </a:rPr>
+              <a:t>•  Query databases</a:t>
+            </a:r>
+          </a:p>
+          <a:p>
+            <a:pPr marL="0" indent="0" algn="l">
+              <a:spcBef>
+                <a:spcPts val="300"/>
+              </a:spcBef>
+              <a:buNone/>
+            </a:pPr>
+            <a:r>
+              <a:rPr lang="en-US" sz="1050" b="0" i="0" dirty="0">
+                <a:solidFill>
+                  <a:srgbClr val="1A2B4C"/>
+                </a:solidFill>
+                <a:latin typeface="Calibri" pitchFamily="34" charset="0"/>
+                <a:cs typeface="Calibri" pitchFamily="34" charset="0"/>
+              </a:rPr>
+              <a:t>•  Access documents</a:t>
+            </a:r>
+          </a:p>
+          <a:p>
+            <a:pPr marL="0" indent="0" algn="l">
+              <a:spcBef>
+                <a:spcPts val="300"/>
+              </a:spcBef>
+              <a:buNone/>
+            </a:pPr>
+            <a:r>
+              <a:rPr lang="en-US" sz="1050" b="0" i="0" dirty="0">
+                <a:solidFill>
+                  <a:srgbClr val="1A2B4C"/>
+                </a:solidFill>
+                <a:latin typeface="Calibri" pitchFamily="34" charset="0"/>
+                <a:cs typeface="Calibri" pitchFamily="34" charset="0"/>
+              </a:rPr>
+              <a:t>•  Read knowledge bases</a:t>
+            </a:r>
+          </a:p>
+          <a:p>
+            <a:pPr marL="0" indent="0" algn="l">
+              <a:spcBef>
+                <a:spcPts val="300"/>
+              </a:spcBef>
+              <a:buNone/>
+            </a:pPr>
+            <a:r>
+              <a:rPr lang="en-US" sz="1050" b="0" i="0" dirty="0">
+                <a:solidFill>
+                  <a:srgbClr val="1A2B4C"/>
+                </a:solidFill>
+                <a:latin typeface="Calibri" pitchFamily="34" charset="0"/>
+                <a:cs typeface="Calibri" pitchFamily="34" charset="0"/>
+              </a:rPr>
+              <a:t>•  Interact with enterprise apps</a:t>
+            </a:r>
+          </a:p>
+        </p:txBody>
+      </p:sp>
+      <p:cxnSp>
+        <p:nvCxnSpPr>
+          <p:cNvPr id="26" name="c26"/>
+          <p:cNvCxnSpPr/>
+          <p:nvPr/>
+        </p:nvCxnSpPr>
+        <p:spPr>
+          <a:xfrm>
+            <a:off x="8050000" y="3520000"/>
+            <a:ext cx="3000000" cy="1"/>
+          </a:xfrm>
+          <a:prstGeom prst="line">
+            <a:avLst/>
+          </a:prstGeom>
+          <a:ln w="19050" cap="rnd">
+            <a:solidFill>
+              <a:srgbClr val="B0BEC5"/>
+            </a:solidFill>
+          </a:ln>
+        </p:spPr>
+      </p:cxnSp>
+      <p:cxnSp>
+        <p:nvCxnSpPr>
+          <p:cNvPr id="27" name="c27"/>
+          <p:cNvCxnSpPr/>
+          <p:nvPr/>
+        </p:nvCxnSpPr>
+        <p:spPr>
+          <a:xfrm flipV="1">
+            <a:off x="8050000" y="1960000"/>
+            <a:ext cx="1500000" cy="1560000"/>
+          </a:xfrm>
+          <a:prstGeom prst="line">
+            <a:avLst/>
+          </a:prstGeom>
+          <a:ln w="19050" cap="rnd">
+            <a:solidFill>
+              <a:srgbClr val="B0BEC5"/>
+            </a:solidFill>
+          </a:ln>
+        </p:spPr>
+      </p:cxnSp>
+      <p:cxnSp>
+        <p:nvCxnSpPr>
+          <p:cNvPr id="28" name="c28"/>
+          <p:cNvCxnSpPr/>
+          <p:nvPr/>
+        </p:nvCxnSpPr>
+        <p:spPr>
+          <a:xfrm flipH="1" flipV="1">
+            <a:off x="6550000" y="1960000"/>
+            <a:ext cx="1500000" cy="1560000"/>
+          </a:xfrm>
+          <a:prstGeom prst="line">
+            <a:avLst/>
+          </a:prstGeom>
+          <a:ln w="19050" cap="rnd">
+            <a:solidFill>
+              <a:srgbClr val="B0BEC5"/>
+            </a:solidFill>
+          </a:ln>
+        </p:spPr>
+      </p:cxnSp>
+      <p:cxnSp>
+        <p:nvCxnSpPr>
+          <p:cNvPr id="29" name="c29"/>
+          <p:cNvCxnSpPr/>
+          <p:nvPr/>
+        </p:nvCxnSpPr>
+        <p:spPr>
+          <a:xfrm flipH="1">
+            <a:off x="5050000" y="3520000"/>
+            <a:ext cx="3000000" cy="1"/>
+          </a:xfrm>
+          <a:prstGeom prst="line">
+            <a:avLst/>
+          </a:prstGeom>
+          <a:ln w="19050" cap="rnd">
+            <a:solidFill>
+              <a:srgbClr val="B0BEC5"/>
+            </a:solidFill>
+          </a:ln>
+        </p:spPr>
+      </p:cxnSp>
+      <p:cxnSp>
+        <p:nvCxnSpPr>
+          <p:cNvPr id="30" name="c30"/>
+          <p:cNvCxnSpPr/>
+          <p:nvPr/>
+        </p:nvCxnSpPr>
+        <p:spPr>
+          <a:xfrm flipH="1">
+            <a:off x="6550000" y="3520000"/>
+            <a:ext cx="1500000" cy="1560000"/>
+          </a:xfrm>
+          <a:prstGeom prst="line">
+            <a:avLst/>
+          </a:prstGeom>
+          <a:ln w="19050" cap="rnd">
+            <a:solidFill>
+              <a:srgbClr val="B0BEC5"/>
+            </a:solidFill>
+          </a:ln>
+        </p:spPr>
+      </p:cxnSp>
+      <p:cxnSp>
+        <p:nvCxnSpPr>
+          <p:cNvPr id="31" name="c31"/>
+          <p:cNvCxnSpPr/>
+          <p:nvPr/>
+        </p:nvCxnSpPr>
+        <p:spPr>
+          <a:xfrm>
+            <a:off x="8050000" y="3520000"/>
+            <a:ext cx="1500000" cy="1560000"/>
+          </a:xfrm>
+          <a:prstGeom prst="line">
+            <a:avLst/>
+          </a:prstGeom>
+          <a:ln w="19050" cap="rnd">
+            <a:solidFill>
+              <a:srgbClr val="B0BEC5"/>
+            </a:solidFill>
+          </a:ln>
+        </p:spPr>
+      </p:cxnSp>
+      <p:sp>
+        <p:nvSpPr>
+          <p:cNvPr id="32" name="hub"/>
+          <p:cNvSpPr/>
+          <p:nvPr/>
+        </p:nvSpPr>
+        <p:spPr>
+          <a:xfrm>
+            <a:off x="7100000" y="3100000"/>
+            <a:ext cx="1900000" cy="840000"/>
+          </a:xfrm>
+          <a:prstGeom prst="roundRect">
+            <a:avLst>
+              <a:gd name="adj" fmla="val 18000"/>
+            </a:avLst>
+          </a:prstGeom>
+          <a:solidFill>
+            <a:srgbClr val="1A2B4C"/>
+          </a:solidFill>
+          <a:ln>
+            <a:noFill/>
+          </a:ln>
+        </p:spPr>
+        <p:txBody>
+          <a:bodyPr wrap="square" rtlCol="0" anchor="ctr" lIns="91440" rIns="91440" tIns="45720" bIns="45720">
+            <a:normAutofit/>
+          </a:bodyPr>
+          <a:lstStyle/>
+          <a:p>
+            <a:pPr marL="0" indent="0" algn="ctr">
+              <a:buNone/>
+            </a:pPr>
+            <a:r>
+              <a:rPr lang="en-US" sz="1600" b="1" i="0" dirty="0">
+                <a:solidFill>
+                  <a:srgbClr val="FFFFFF"/>
+                </a:solidFill>
+                <a:latin typeface="Calibri" pitchFamily="34" charset="0"/>
+                <a:cs typeface="Calibri" pitchFamily="34" charset="0"/>
+              </a:rPr>
+              <a:t>Claude</a:t>
+            </a:r>
+          </a:p>
+          <a:p>
+            <a:pPr marL="0" indent="0" algn="ctr">
+              <a:buNone/>
+            </a:pPr>
+            <a:r>
+              <a:rPr lang="en-US" sz="950" b="0" i="0" dirty="0">
+                <a:solidFill>
+                  <a:srgbClr val="E3F0FF"/>
+                </a:solidFill>
+                <a:latin typeface="Calibri" pitchFamily="34" charset="0"/>
+                <a:cs typeface="Calibri" pitchFamily="34" charset="0"/>
+              </a:rPr>
+              <a:t>AI Assistant</a:t>
+            </a:r>
+          </a:p>
+        </p:txBody>
+      </p:sp>
+      <p:sp>
+        <p:nvSpPr>
+          <p:cNvPr id="33" name="nd"/>
+          <p:cNvSpPr/>
+          <p:nvPr/>
+        </p:nvSpPr>
+        <p:spPr>
+          <a:xfrm>
+            <a:off x="10075000" y="3210000"/>
+            <a:ext cx="1950000" cy="620000"/>
+          </a:xfrm>
+          <a:prstGeom prst="roundRect">
+            <a:avLst>
+              <a:gd name="adj" fmla="val 16000"/>
+            </a:avLst>
+          </a:prstGeom>
+          <a:solidFill>
+            <a:srgbClr val="FFFFFF"/>
+          </a:solidFill>
+          <a:ln w="22225">
+            <a:solidFill>
+              <a:srgbClr val="1565C0"/>
+            </a:solidFill>
+          </a:ln>
+        </p:spPr>
+        <p:txBody>
+          <a:bodyPr wrap="square" rtlCol="0" anchor="ctr" lIns="91440" rIns="91440" tIns="45720" bIns="45720">
+            <a:normAutofit/>
+          </a:bodyPr>
+          <a:lstStyle/>
+          <a:p>
+            <a:pPr marL="0" indent="0" algn="ctr">
+              <a:buNone/>
+            </a:pPr>
+            <a:r>
+              <a:rPr lang="en-US" sz="1100" b="1" i="0" dirty="0">
+                <a:solidFill>
+                  <a:srgbClr val="1565C0"/>
+                </a:solidFill>
+                <a:latin typeface="Calibri" pitchFamily="34" charset="0"/>
+                <a:cs typeface="Calibri" pitchFamily="34" charset="0"/>
+              </a:rPr>
+              <a:t>SharePoint</a:t>
+            </a:r>
+          </a:p>
+        </p:txBody>
+      </p:sp>
+      <p:sp>
+        <p:nvSpPr>
+          <p:cNvPr id="34" name="nd"/>
+          <p:cNvSpPr/>
+          <p:nvPr/>
+        </p:nvSpPr>
+        <p:spPr>
+          <a:xfrm>
+            <a:off x="8575000" y="1650000"/>
+            <a:ext cx="1950000" cy="620000"/>
+          </a:xfrm>
+          <a:prstGeom prst="roundRect">
+            <a:avLst>
+              <a:gd name="adj" fmla="val 16000"/>
+            </a:avLst>
+          </a:prstGeom>
+          <a:solidFill>
+            <a:srgbClr val="FFFFFF"/>
+          </a:solidFill>
+          <a:ln w="22225">
+            <a:solidFill>
+              <a:srgbClr val="5E35B1"/>
+            </a:solidFill>
+          </a:ln>
+        </p:spPr>
+        <p:txBody>
+          <a:bodyPr wrap="square" rtlCol="0" anchor="ctr" lIns="91440" rIns="91440" tIns="45720" bIns="45720">
+            <a:normAutofit/>
+          </a:bodyPr>
+          <a:lstStyle/>
+          <a:p>
+            <a:pPr marL="0" indent="0" algn="ctr">
+              <a:buNone/>
+            </a:pPr>
+            <a:r>
+              <a:rPr lang="en-US" sz="1100" b="1" i="0" dirty="0">
+                <a:solidFill>
+                  <a:srgbClr val="5E35B1"/>
+                </a:solidFill>
+                <a:latin typeface="Calibri" pitchFamily="34" charset="0"/>
+                <a:cs typeface="Calibri" pitchFamily="34" charset="0"/>
+              </a:rPr>
+              <a:t>Salesforce</a:t>
+            </a:r>
+          </a:p>
+        </p:txBody>
+      </p:sp>
+      <p:sp>
+        <p:nvSpPr>
+          <p:cNvPr id="35" name="nd"/>
+          <p:cNvSpPr/>
+          <p:nvPr/>
+        </p:nvSpPr>
+        <p:spPr>
+          <a:xfrm>
+            <a:off x="5575000" y="1650000"/>
+            <a:ext cx="1950000" cy="620000"/>
+          </a:xfrm>
+          <a:prstGeom prst="roundRect">
+            <a:avLst>
+              <a:gd name="adj" fmla="val 16000"/>
+            </a:avLst>
+          </a:prstGeom>
+          <a:solidFill>
+            <a:srgbClr val="FFFFFF"/>
+          </a:solidFill>
+          <a:ln w="22225">
+            <a:solidFill>
+              <a:srgbClr val="00897B"/>
+            </a:solidFill>
+          </a:ln>
+        </p:spPr>
+        <p:txBody>
+          <a:bodyPr wrap="square" rtlCol="0" anchor="ctr" lIns="91440" rIns="91440" tIns="45720" bIns="45720">
+            <a:normAutofit/>
+          </a:bodyPr>
+          <a:lstStyle/>
+          <a:p>
+            <a:pPr marL="0" indent="0" algn="ctr">
+              <a:buNone/>
+            </a:pPr>
+            <a:r>
+              <a:rPr lang="en-US" sz="1100" b="1" i="0" dirty="0">
+                <a:solidFill>
+                  <a:srgbClr val="00897B"/>
+                </a:solidFill>
+                <a:latin typeface="Calibri" pitchFamily="34" charset="0"/>
+                <a:cs typeface="Calibri" pitchFamily="34" charset="0"/>
+              </a:rPr>
+              <a:t>Healthcare KB</a:t>
+            </a:r>
+          </a:p>
+        </p:txBody>
+      </p:sp>
+      <p:sp>
+        <p:nvSpPr>
+          <p:cNvPr id="36" name="nd"/>
+          <p:cNvSpPr/>
+          <p:nvPr/>
+        </p:nvSpPr>
+        <p:spPr>
+          <a:xfrm>
+            <a:off x="4075000" y="3210000"/>
+            <a:ext cx="1950000" cy="620000"/>
+          </a:xfrm>
+          <a:prstGeom prst="roundRect">
+            <a:avLst>
+              <a:gd name="adj" fmla="val 16000"/>
+            </a:avLst>
+          </a:prstGeom>
+          <a:solidFill>
+            <a:srgbClr val="FFFFFF"/>
+          </a:solidFill>
+          <a:ln w="22225">
+            <a:solidFill>
+              <a:srgbClr val="1565C0"/>
+            </a:solidFill>
+          </a:ln>
+        </p:spPr>
+        <p:txBody>
+          <a:bodyPr wrap="square" rtlCol="0" anchor="ctr" lIns="91440" rIns="91440" tIns="45720" bIns="45720">
+            <a:normAutofit/>
+          </a:bodyPr>
+          <a:lstStyle/>
+          <a:p>
+            <a:pPr marL="0" indent="0" algn="ctr">
+              <a:buNone/>
+            </a:pPr>
+            <a:r>
+              <a:rPr lang="en-US" sz="1100" b="1" i="0" dirty="0">
+                <a:solidFill>
+                  <a:srgbClr val="1565C0"/>
+                </a:solidFill>
+                <a:latin typeface="Calibri" pitchFamily="34" charset="0"/>
+                <a:cs typeface="Calibri" pitchFamily="34" charset="0"/>
+              </a:rPr>
+              <a:t>SQL Database</a:t>
+            </a:r>
+          </a:p>
+        </p:txBody>
+      </p:sp>
+      <p:sp>
+        <p:nvSpPr>
+          <p:cNvPr id="37" name="nd"/>
+          <p:cNvSpPr/>
+          <p:nvPr/>
+        </p:nvSpPr>
+        <p:spPr>
+          <a:xfrm>
+            <a:off x="5575000" y="4770000"/>
+            <a:ext cx="1950000" cy="620000"/>
+          </a:xfrm>
+          <a:prstGeom prst="roundRect">
+            <a:avLst>
+              <a:gd name="adj" fmla="val 16000"/>
+            </a:avLst>
+          </a:prstGeom>
+          <a:solidFill>
+            <a:srgbClr val="FFFFFF"/>
+          </a:solidFill>
+          <a:ln w="22225">
+            <a:solidFill>
+              <a:srgbClr val="00897B"/>
+            </a:solidFill>
+          </a:ln>
+        </p:spPr>
+        <p:txBody>
+          <a:bodyPr wrap="square" rtlCol="0" anchor="ctr" lIns="91440" rIns="91440" tIns="45720" bIns="45720">
+            <a:normAutofit/>
+          </a:bodyPr>
+          <a:lstStyle/>
+          <a:p>
+            <a:pPr marL="0" indent="0" algn="ctr">
+              <a:buNone/>
+            </a:pPr>
+            <a:r>
+              <a:rPr lang="en-US" sz="1100" b="1" i="0" dirty="0">
+                <a:solidFill>
+                  <a:srgbClr val="00897B"/>
+                </a:solidFill>
+                <a:latin typeface="Calibri" pitchFamily="34" charset="0"/>
+                <a:cs typeface="Calibri" pitchFamily="34" charset="0"/>
+              </a:rPr>
+              <a:t>Jira</a:t>
+            </a:r>
+          </a:p>
+        </p:txBody>
+      </p:sp>
+      <p:sp>
+        <p:nvSpPr>
+          <p:cNvPr id="38" name="nd"/>
+          <p:cNvSpPr/>
+          <p:nvPr/>
+        </p:nvSpPr>
+        <p:spPr>
+          <a:xfrm>
+            <a:off x="8575000" y="4770000"/>
+            <a:ext cx="1950000" cy="620000"/>
+          </a:xfrm>
+          <a:prstGeom prst="roundRect">
+            <a:avLst>
+              <a:gd name="adj" fmla="val 16000"/>
+            </a:avLst>
+          </a:prstGeom>
+          <a:solidFill>
+            <a:srgbClr val="FFFFFF"/>
+          </a:solidFill>
+          <a:ln w="22225">
+            <a:solidFill>
+              <a:srgbClr val="5E35B1"/>
+            </a:solidFill>
+          </a:ln>
+        </p:spPr>
+        <p:txBody>
+          <a:bodyPr wrap="square" rtlCol="0" anchor="ctr" lIns="91440" rIns="91440" tIns="45720" bIns="45720">
+            <a:normAutofit/>
+          </a:bodyPr>
+          <a:lstStyle/>
+          <a:p>
+            <a:pPr marL="0" indent="0" algn="ctr">
+              <a:buNone/>
+            </a:pPr>
+            <a:r>
+              <a:rPr lang="en-US" sz="1100" b="1" i="0" dirty="0">
+                <a:solidFill>
+                  <a:srgbClr val="5E35B1"/>
+                </a:solidFill>
+                <a:latin typeface="Calibri" pitchFamily="34" charset="0"/>
+                <a:cs typeface="Calibri" pitchFamily="34" charset="0"/>
+              </a:rPr>
+              <a:t>APIs</a:t>
+            </a:r>
+          </a:p>
+        </p:txBody>
+      </p:sp>
+      <p:sp>
+        <p:nvSpPr>
+          <p:cNvPr id="39" name="callout"/>
+          <p:cNvSpPr/>
+          <p:nvPr/>
+        </p:nvSpPr>
+        <p:spPr>
+          <a:xfrm>
+            <a:off x="3760000" y="5850000"/>
+            <a:ext cx="8200000" cy="470000"/>
+          </a:xfrm>
+          <a:prstGeom prst="roundRect">
+            <a:avLst>
+              <a:gd name="adj" fmla="val 14000"/>
+            </a:avLst>
+          </a:prstGeom>
+          <a:solidFill>
+            <a:srgbClr val="1A2B4C"/>
+          </a:solidFill>
+          <a:ln>
+            <a:noFill/>
+          </a:ln>
+        </p:spPr>
+        <p:txBody>
+          <a:bodyPr wrap="square" rtlCol="0" anchor="ctr" lIns="91440" rIns="91440" tIns="45720" bIns="45720">
+            <a:normAutofit/>
+          </a:bodyPr>
+          <a:lstStyle/>
+          <a:p>
+            <a:pPr marL="0" indent="0" algn="ctr">
+              <a:buNone/>
+            </a:pPr>
+            <a:r>
+              <a:rPr lang="en-US" sz="1300" b="1" i="1" dirty="0">
+                <a:solidFill>
+                  <a:srgbClr val="FFFFFF"/>
+                </a:solidFill>
+                <a:latin typeface="Calibri" pitchFamily="34" charset="0"/>
+                <a:cs typeface="Calibri" pitchFamily="34" charset="0"/>
+              </a:rPr>
+              <a:t>“MCP transforms Claude from a chatbot into an enterprise assistant.”</a:t>
+            </a:r>
+          </a:p>
+        </p:txBody>
+      </p:sp>
+      <p:sp>
+        <p:nvSpPr>
+          <p:cNvPr id="40" name="Footer"/>
+          <p:cNvSpPr/>
+          <p:nvPr/>
+        </p:nvSpPr>
+        <p:spPr>
+          <a:xfrm>
+            <a:off x="182880" y="6413602"/>
+            <a:ext cx="6984187" cy="444398"/>
+          </a:xfrm>
+          <a:prstGeom prst="rect">
+            <a:avLst/>
+          </a:prstGeom>
+          <a:noFill/>
+          <a:ln>
+            <a:noFill/>
+          </a:ln>
+        </p:spPr>
+        <p:txBody>
+          <a:bodyPr wrap="square" rtlCol="0" anchor="ctr" lIns="91440" rIns="91440" tIns="45720" bIns="45720">
+            <a:normAutofit/>
+          </a:bodyPr>
+          <a:lstStyle/>
+          <a:p>
+            <a:pPr marL="0" indent="0" algn="l">
+              <a:buNone/>
+            </a:pPr>
+            <a:r>
+              <a:rPr lang="en-US" sz="700" b="0" i="0" dirty="0">
+                <a:solidFill>
+                  <a:srgbClr val="64748B"/>
+                </a:solidFill>
+                <a:latin typeface="Calibri" pitchFamily="34" charset="0"/>
+                <a:cs typeface="Calibri" pitchFamily="34" charset="0"/>
+              </a:rPr>
+              <a:t>1455 LINCOLN PARKWAY EAST, 8TH FLOOR, ATLANTA, GA 30346 | WWW.INNOVASOLUTIONS.COM</a:t>
+            </a:r>
+          </a:p>
+        </p:txBody>
+      </p:sp>
+      <p:pic>
+        <p:nvPicPr>
+          <p:cNvPr id="41" name="Logo"/>
+          <p:cNvPicPr>
+            <a:picLocks noChangeAspect="1"/>
+          </p:cNvPicPr>
+          <p:nvPr/>
+        </p:nvPicPr>
+        <p:blipFill>
+          <a:blip r:embed="rId2"/>
+          <a:stretch>
+            <a:fillRect/>
+          </a:stretch>
+        </p:blipFill>
+        <p:spPr>
+          <a:xfrm>
+            <a:off x="9960940" y="103430"/>
+            <a:ext cx="2040941" cy="769925"/>
+          </a:xfrm>
+          <a:prstGeom prst="rect">
+            <a:avLst/>
+          </a:prstGeom>
+        </p:spPr>
+      </p:pic>
+    </p:spTree>
+  </p:cSld>
+  <p:clrMapOvr>
+    <a:masterClrMapping/>
+  </p:clrMapOvr>
+</p:sld>
+</file>
+
+<file path=ppt/slides/slide15.xml><?xml version="1.0" encoding="utf-8"?>
+<p:sld xmlns:a="http://schemas.openxmlformats.org/drawingml/2006/main" xmlns:r="http://schemas.openxmlformats.org/officeDocument/2006/relationships" xmlns:p="http://schemas.openxmlformats.org/presentationml/2006/main">
+  <p:cSld>
+    <p:spTree>
+      <p:nvGrpSpPr>
+        <p:cNvPr id="1" name=""/>
+        <p:cNvGrpSpPr/>
+        <p:nvPr/>
+      </p:nvGrpSpPr>
+      <p:grpSpPr>
+        <a:xfrm>
+          <a:off x="0" y="0"/>
+          <a:ext cx="0" cy="0"/>
+          <a:chOff x="0" y="0"/>
+          <a:chExt cx="0" cy="0"/>
+        </a:xfrm>
+      </p:grpSpPr>
+      <p:sp>
+        <p:nvSpPr>
+          <p:cNvPr id="10" name="Title"/>
+          <p:cNvSpPr/>
+          <p:nvPr/>
+        </p:nvSpPr>
+        <p:spPr>
+          <a:xfrm>
+            <a:off x="313752" y="266276"/>
+            <a:ext cx="9550000" cy="470000"/>
+          </a:xfrm>
+          <a:prstGeom prst="rect">
+            <a:avLst/>
+          </a:prstGeom>
+          <a:noFill/>
+          <a:ln>
+            <a:noFill/>
+          </a:ln>
+        </p:spPr>
+        <p:txBody>
+          <a:bodyPr wrap="square" rtlCol="0" anchor="t" lIns="91440" rIns="91440" tIns="45720" bIns="45720">
+            <a:normAutofit/>
+          </a:bodyPr>
+          <a:lstStyle/>
+          <a:p>
+            <a:pPr marL="0" indent="0" algn="l">
+              <a:buNone/>
+            </a:pPr>
+            <a:r>
+              <a:rPr lang="en-US" sz="2800" b="1" i="0" dirty="0">
+                <a:solidFill>
+                  <a:srgbClr val="1A2B4C"/>
+                </a:solidFill>
+                <a:latin typeface="Aptos" pitchFamily="34" charset="0"/>
+                <a:cs typeface="Aptos" pitchFamily="34" charset="0"/>
+              </a:rPr>
+              <a:t>AI Agents: Moving Beyond Questions &amp; Answers</a:t>
+            </a:r>
+          </a:p>
+        </p:txBody>
+      </p:sp>
+      <p:sp>
+        <p:nvSpPr>
+          <p:cNvPr id="11" name="Subtitle"/>
+          <p:cNvSpPr/>
+          <p:nvPr/>
+        </p:nvSpPr>
+        <p:spPr>
+          <a:xfrm>
+            <a:off x="313752" y="760000"/>
+            <a:ext cx="9269611" cy="470000"/>
+          </a:xfrm>
+          <a:prstGeom prst="rect">
+            <a:avLst/>
+          </a:prstGeom>
+          <a:noFill/>
+          <a:ln>
+            <a:noFill/>
+          </a:ln>
+        </p:spPr>
+        <p:txBody>
+          <a:bodyPr wrap="square" rtlCol="0" anchor="t" lIns="91440" rIns="91440" tIns="45720" bIns="45720">
+            <a:normAutofit/>
+          </a:bodyPr>
+          <a:lstStyle/>
+          <a:p>
+            <a:pPr marL="0" indent="0" algn="l">
+              <a:buNone/>
+            </a:pPr>
+            <a:r>
+              <a:rPr lang="en-US" sz="1300" b="0" i="1" dirty="0">
+                <a:solidFill>
+                  <a:srgbClr val="153D64"/>
+                </a:solidFill>
+                <a:latin typeface="Calibri" pitchFamily="34" charset="0"/>
+                <a:cs typeface="Calibri" pitchFamily="34" charset="0"/>
+              </a:rPr>
+              <a:t>Traditional AI answers questions. AI Agents plan, reason, use tools, and execute multi-step tasks toward a goal.</a:t>
+            </a:r>
+          </a:p>
+        </p:txBody>
+      </p:sp>
+      <p:sp>
+        <p:nvSpPr>
+          <p:cNvPr id="20" name="tlab"/>
+          <p:cNvSpPr/>
+          <p:nvPr/>
+        </p:nvSpPr>
+        <p:spPr>
+          <a:xfrm>
+            <a:off x="313752" y="1320000"/>
+            <a:ext cx="1850000" cy="470000"/>
+          </a:xfrm>
+          <a:prstGeom prst="rect">
+            <a:avLst/>
+          </a:prstGeom>
+          <a:noFill/>
+          <a:ln>
+            <a:noFill/>
+          </a:ln>
+        </p:spPr>
+        <p:txBody>
+          <a:bodyPr wrap="square" rtlCol="0" anchor="ctr" lIns="91440" rIns="91440" tIns="45720" bIns="45720">
+            <a:normAutofit/>
+          </a:bodyPr>
+          <a:lstStyle/>
+          <a:p>
+            <a:pPr marL="0" indent="0" algn="l">
+              <a:buNone/>
+            </a:pPr>
+            <a:r>
+              <a:rPr lang="en-US" sz="1100" b="1" i="0" dirty="0">
+                <a:solidFill>
+                  <a:srgbClr val="546E7A"/>
+                </a:solidFill>
+                <a:latin typeface="Calibri" pitchFamily="34" charset="0"/>
+                <a:cs typeface="Calibri" pitchFamily="34" charset="0"/>
+              </a:rPr>
+              <a:t>Traditional AI</a:t>
+            </a:r>
+          </a:p>
+        </p:txBody>
+      </p:sp>
+      <p:sp>
+        <p:nvSpPr>
+          <p:cNvPr id="21" name="trad"/>
+          <p:cNvSpPr/>
+          <p:nvPr/>
+        </p:nvSpPr>
+        <p:spPr>
+          <a:xfrm>
+            <a:off x="2230000" y="1320000"/>
+            <a:ext cx="9650000" cy="470000"/>
+          </a:xfrm>
+          <a:prstGeom prst="roundRect">
+            <a:avLst>
+              <a:gd name="adj" fmla="val 20000"/>
+            </a:avLst>
+          </a:prstGeom>
+          <a:solidFill>
+            <a:srgbClr val="F1F5F9"/>
+          </a:solidFill>
+          <a:ln>
+            <a:noFill/>
+          </a:ln>
+        </p:spPr>
+        <p:txBody>
+          <a:bodyPr wrap="square" rtlCol="0" anchor="ctr" lIns="91440" rIns="91440" tIns="45720" bIns="45720">
+            <a:normAutofit/>
+          </a:bodyPr>
+          <a:lstStyle/>
+          <a:p>
+            <a:pPr marL="0" indent="0" algn="ctr">
+              <a:buNone/>
+            </a:pPr>
+            <a:r>
+              <a:rPr lang="en-US" sz="1300" b="1" i="0" dirty="0">
+                <a:solidFill>
+                  <a:srgbClr val="546E7A"/>
+                </a:solidFill>
+                <a:latin typeface="Calibri" pitchFamily="34" charset="0"/>
+                <a:cs typeface="Calibri" pitchFamily="34" charset="0"/>
+              </a:rPr>
+              <a:t>User    →    Prompt    →    Response</a:t>
+            </a:r>
+          </a:p>
+        </p:txBody>
+      </p:sp>
+      <p:sp>
+        <p:nvSpPr>
+          <p:cNvPr id="22" name="alab"/>
+          <p:cNvSpPr/>
+          <p:nvPr/>
+        </p:nvSpPr>
+        <p:spPr>
+          <a:xfrm>
+            <a:off x="313752" y="1980000"/>
+            <a:ext cx="9650000" cy="360000"/>
+          </a:xfrm>
+          <a:prstGeom prst="rect">
+            <a:avLst/>
+          </a:prstGeom>
+          <a:noFill/>
+          <a:ln>
+            <a:noFill/>
+          </a:ln>
+        </p:spPr>
+        <p:txBody>
+          <a:bodyPr wrap="square" rtlCol="0" anchor="ctr" lIns="91440" rIns="91440" tIns="45720" bIns="45720">
+            <a:normAutofit/>
+          </a:bodyPr>
+          <a:lstStyle/>
+          <a:p>
+            <a:pPr marL="0" indent="0" algn="l">
+              <a:buNone/>
+            </a:pPr>
+            <a:r>
+              <a:rPr lang="en-US" sz="1200" b="1" i="0" dirty="0">
+                <a:solidFill>
+                  <a:srgbClr val="1A2B4C"/>
+                </a:solidFill>
+                <a:latin typeface="Calibri" pitchFamily="34" charset="0"/>
+                <a:cs typeface="Calibri" pitchFamily="34" charset="0"/>
+              </a:rPr>
+              <a:t>Agent Workflow</a:t>
+            </a:r>
+          </a:p>
+        </p:txBody>
+      </p:sp>
+      <p:sp>
+        <p:nvSpPr>
+          <p:cNvPr id="23" name="st"/>
+          <p:cNvSpPr/>
+          <p:nvPr/>
+        </p:nvSpPr>
+        <p:spPr>
+          <a:xfrm>
+            <a:off x="313752" y="2380000"/>
+            <a:ext cx="1800000" cy="620000"/>
+          </a:xfrm>
+          <a:prstGeom prst="roundRect">
+            <a:avLst>
+              <a:gd name="adj" fmla="val 16000"/>
+            </a:avLst>
+          </a:prstGeom>
+          <a:solidFill>
+            <a:srgbClr val="1565C0"/>
+          </a:solidFill>
+          <a:ln>
+            <a:noFill/>
+          </a:ln>
+        </p:spPr>
+        <p:txBody>
+          <a:bodyPr wrap="square" rtlCol="0" anchor="ctr" lIns="91440" rIns="91440" tIns="45720" bIns="45720">
+            <a:normAutofit/>
+          </a:bodyPr>
+          <a:lstStyle/>
+          <a:p>
+            <a:pPr marL="0" indent="0" algn="ctr">
+              <a:buNone/>
+            </a:pPr>
+            <a:r>
+              <a:rPr lang="en-US" sz="900" b="1" i="0" dirty="0">
+                <a:solidFill>
+                  <a:srgbClr val="FFFFFF"/>
+                </a:solidFill>
+                <a:latin typeface="Calibri" pitchFamily="34" charset="0"/>
+                <a:cs typeface="Calibri" pitchFamily="34" charset="0"/>
+              </a:rPr>
+              <a:t>1</a:t>
+            </a:r>
+          </a:p>
+          <a:p>
+            <a:pPr marL="0" indent="0" algn="ctr">
+              <a:buNone/>
+            </a:pPr>
+            <a:r>
+              <a:rPr lang="en-US" sz="1250" b="1" i="0" dirty="0">
+                <a:solidFill>
+                  <a:srgbClr val="FFFFFF"/>
+                </a:solidFill>
+                <a:latin typeface="Calibri" pitchFamily="34" charset="0"/>
+                <a:cs typeface="Calibri" pitchFamily="34" charset="0"/>
+              </a:rPr>
+              <a:t>Goal</a:t>
+            </a:r>
+          </a:p>
+        </p:txBody>
+      </p:sp>
+      <p:sp>
+        <p:nvSpPr>
+          <p:cNvPr id="24" name="st"/>
+          <p:cNvSpPr/>
+          <p:nvPr/>
+        </p:nvSpPr>
+        <p:spPr>
+          <a:xfrm>
+            <a:off x="2263752" y="2380000"/>
+            <a:ext cx="1800000" cy="620000"/>
+          </a:xfrm>
+          <a:prstGeom prst="roundRect">
+            <a:avLst>
+              <a:gd name="adj" fmla="val 16000"/>
+            </a:avLst>
+          </a:prstGeom>
+          <a:solidFill>
+            <a:srgbClr val="00897B"/>
+          </a:solidFill>
+          <a:ln>
+            <a:noFill/>
+          </a:ln>
+        </p:spPr>
+        <p:txBody>
+          <a:bodyPr wrap="square" rtlCol="0" anchor="ctr" lIns="91440" rIns="91440" tIns="45720" bIns="45720">
+            <a:normAutofit/>
+          </a:bodyPr>
+          <a:lstStyle/>
+          <a:p>
+            <a:pPr marL="0" indent="0" algn="ctr">
+              <a:buNone/>
+            </a:pPr>
+            <a:r>
+              <a:rPr lang="en-US" sz="900" b="1" i="0" dirty="0">
+                <a:solidFill>
+                  <a:srgbClr val="FFFFFF"/>
+                </a:solidFill>
+                <a:latin typeface="Calibri" pitchFamily="34" charset="0"/>
+                <a:cs typeface="Calibri" pitchFamily="34" charset="0"/>
+              </a:rPr>
+              <a:t>2</a:t>
+            </a:r>
+          </a:p>
+          <a:p>
+            <a:pPr marL="0" indent="0" algn="ctr">
+              <a:buNone/>
+            </a:pPr>
+            <a:r>
+              <a:rPr lang="en-US" sz="1250" b="1" i="0" dirty="0">
+                <a:solidFill>
+                  <a:srgbClr val="FFFFFF"/>
+                </a:solidFill>
+                <a:latin typeface="Calibri" pitchFamily="34" charset="0"/>
+                <a:cs typeface="Calibri" pitchFamily="34" charset="0"/>
+              </a:rPr>
+              <a:t>Plan</a:t>
+            </a:r>
+          </a:p>
+        </p:txBody>
+      </p:sp>
+      <p:sp>
+        <p:nvSpPr>
+          <p:cNvPr id="25" name="st"/>
+          <p:cNvSpPr/>
+          <p:nvPr/>
+        </p:nvSpPr>
+        <p:spPr>
+          <a:xfrm>
+            <a:off x="4213752" y="2380000"/>
+            <a:ext cx="1800000" cy="620000"/>
+          </a:xfrm>
+          <a:prstGeom prst="roundRect">
+            <a:avLst>
+              <a:gd name="adj" fmla="val 16000"/>
+            </a:avLst>
+          </a:prstGeom>
+          <a:solidFill>
+            <a:srgbClr val="5E35B1"/>
+          </a:solidFill>
+          <a:ln>
+            <a:noFill/>
+          </a:ln>
+        </p:spPr>
+        <p:txBody>
+          <a:bodyPr wrap="square" rtlCol="0" anchor="ctr" lIns="91440" rIns="91440" tIns="45720" bIns="45720">
+            <a:normAutofit/>
+          </a:bodyPr>
+          <a:lstStyle/>
+          <a:p>
+            <a:pPr marL="0" indent="0" algn="ctr">
+              <a:buNone/>
+            </a:pPr>
+            <a:r>
+              <a:rPr lang="en-US" sz="900" b="1" i="0" dirty="0">
+                <a:solidFill>
+                  <a:srgbClr val="FFFFFF"/>
+                </a:solidFill>
+                <a:latin typeface="Calibri" pitchFamily="34" charset="0"/>
+                <a:cs typeface="Calibri" pitchFamily="34" charset="0"/>
+              </a:rPr>
+              <a:t>3</a:t>
+            </a:r>
+          </a:p>
+          <a:p>
+            <a:pPr marL="0" indent="0" algn="ctr">
+              <a:buNone/>
+            </a:pPr>
+            <a:r>
+              <a:rPr lang="en-US" sz="1250" b="1" i="0" dirty="0">
+                <a:solidFill>
+                  <a:srgbClr val="FFFFFF"/>
+                </a:solidFill>
+                <a:latin typeface="Calibri" pitchFamily="34" charset="0"/>
+                <a:cs typeface="Calibri" pitchFamily="34" charset="0"/>
+              </a:rPr>
+              <a:t>Tools</a:t>
+            </a:r>
+          </a:p>
+        </p:txBody>
+      </p:sp>
+      <p:sp>
+        <p:nvSpPr>
+          <p:cNvPr id="26" name="st"/>
+          <p:cNvSpPr/>
+          <p:nvPr/>
+        </p:nvSpPr>
+        <p:spPr>
+          <a:xfrm>
+            <a:off x="6163752" y="2380000"/>
+            <a:ext cx="1800000" cy="620000"/>
+          </a:xfrm>
+          <a:prstGeom prst="roundRect">
+            <a:avLst>
+              <a:gd name="adj" fmla="val 16000"/>
+            </a:avLst>
+          </a:prstGeom>
+          <a:solidFill>
+            <a:srgbClr val="1565C0"/>
+          </a:solidFill>
+          <a:ln>
+            <a:noFill/>
+          </a:ln>
+        </p:spPr>
+        <p:txBody>
+          <a:bodyPr wrap="square" rtlCol="0" anchor="ctr" lIns="91440" rIns="91440" tIns="45720" bIns="45720">
+            <a:normAutofit/>
+          </a:bodyPr>
+          <a:lstStyle/>
+          <a:p>
+            <a:pPr marL="0" indent="0" algn="ctr">
+              <a:buNone/>
+            </a:pPr>
+            <a:r>
+              <a:rPr lang="en-US" sz="900" b="1" i="0" dirty="0">
+                <a:solidFill>
+                  <a:srgbClr val="FFFFFF"/>
+                </a:solidFill>
+                <a:latin typeface="Calibri" pitchFamily="34" charset="0"/>
+                <a:cs typeface="Calibri" pitchFamily="34" charset="0"/>
+              </a:rPr>
+              <a:t>4</a:t>
+            </a:r>
+          </a:p>
+          <a:p>
+            <a:pPr marL="0" indent="0" algn="ctr">
+              <a:buNone/>
+            </a:pPr>
+            <a:r>
+              <a:rPr lang="en-US" sz="1250" b="1" i="0" dirty="0">
+                <a:solidFill>
+                  <a:srgbClr val="FFFFFF"/>
+                </a:solidFill>
+                <a:latin typeface="Calibri" pitchFamily="34" charset="0"/>
+                <a:cs typeface="Calibri" pitchFamily="34" charset="0"/>
+              </a:rPr>
+              <a:t>Execute</a:t>
+            </a:r>
+          </a:p>
+        </p:txBody>
+      </p:sp>
+      <p:sp>
+        <p:nvSpPr>
+          <p:cNvPr id="27" name="st"/>
+          <p:cNvSpPr/>
+          <p:nvPr/>
+        </p:nvSpPr>
+        <p:spPr>
+          <a:xfrm>
+            <a:off x="8113752" y="2380000"/>
+            <a:ext cx="1800000" cy="620000"/>
+          </a:xfrm>
+          <a:prstGeom prst="roundRect">
+            <a:avLst>
+              <a:gd name="adj" fmla="val 16000"/>
+            </a:avLst>
+          </a:prstGeom>
+          <a:solidFill>
+            <a:srgbClr val="00897B"/>
+          </a:solidFill>
+          <a:ln>
+            <a:noFill/>
+          </a:ln>
+        </p:spPr>
+        <p:txBody>
+          <a:bodyPr wrap="square" rtlCol="0" anchor="ctr" lIns="91440" rIns="91440" tIns="45720" bIns="45720">
+            <a:normAutofit/>
+          </a:bodyPr>
+          <a:lstStyle/>
+          <a:p>
+            <a:pPr marL="0" indent="0" algn="ctr">
+              <a:buNone/>
+            </a:pPr>
+            <a:r>
+              <a:rPr lang="en-US" sz="900" b="1" i="0" dirty="0">
+                <a:solidFill>
+                  <a:srgbClr val="FFFFFF"/>
+                </a:solidFill>
+                <a:latin typeface="Calibri" pitchFamily="34" charset="0"/>
+                <a:cs typeface="Calibri" pitchFamily="34" charset="0"/>
+              </a:rPr>
+              <a:t>5</a:t>
+            </a:r>
+          </a:p>
+          <a:p>
+            <a:pPr marL="0" indent="0" algn="ctr">
+              <a:buNone/>
+            </a:pPr>
+            <a:r>
+              <a:rPr lang="en-US" sz="1250" b="1" i="0" dirty="0">
+                <a:solidFill>
+                  <a:srgbClr val="FFFFFF"/>
+                </a:solidFill>
+                <a:latin typeface="Calibri" pitchFamily="34" charset="0"/>
+                <a:cs typeface="Calibri" pitchFamily="34" charset="0"/>
+              </a:rPr>
+              <a:t>Validate</a:t>
+            </a:r>
+          </a:p>
+        </p:txBody>
+      </p:sp>
+      <p:sp>
+        <p:nvSpPr>
+          <p:cNvPr id="28" name="st"/>
+          <p:cNvSpPr/>
+          <p:nvPr/>
+        </p:nvSpPr>
+        <p:spPr>
+          <a:xfrm>
+            <a:off x="10063752" y="2380000"/>
+            <a:ext cx="1800000" cy="620000"/>
+          </a:xfrm>
+          <a:prstGeom prst="roundRect">
+            <a:avLst>
+              <a:gd name="adj" fmla="val 16000"/>
+            </a:avLst>
+          </a:prstGeom>
+          <a:solidFill>
+            <a:srgbClr val="5E35B1"/>
+          </a:solidFill>
+          <a:ln>
+            <a:noFill/>
+          </a:ln>
+        </p:spPr>
+        <p:txBody>
+          <a:bodyPr wrap="square" rtlCol="0" anchor="ctr" lIns="91440" rIns="91440" tIns="45720" bIns="45720">
+            <a:normAutofit/>
+          </a:bodyPr>
+          <a:lstStyle/>
+          <a:p>
+            <a:pPr marL="0" indent="0" algn="ctr">
+              <a:buNone/>
+            </a:pPr>
+            <a:r>
+              <a:rPr lang="en-US" sz="900" b="1" i="0" dirty="0">
+                <a:solidFill>
+                  <a:srgbClr val="FFFFFF"/>
+                </a:solidFill>
+                <a:latin typeface="Calibri" pitchFamily="34" charset="0"/>
+                <a:cs typeface="Calibri" pitchFamily="34" charset="0"/>
+              </a:rPr>
+              <a:t>6</a:t>
+            </a:r>
+          </a:p>
+          <a:p>
+            <a:pPr marL="0" indent="0" algn="ctr">
+              <a:buNone/>
+            </a:pPr>
+            <a:r>
+              <a:rPr lang="en-US" sz="1250" b="1" i="0" dirty="0">
+                <a:solidFill>
+                  <a:srgbClr val="FFFFFF"/>
+                </a:solidFill>
+                <a:latin typeface="Calibri" pitchFamily="34" charset="0"/>
+                <a:cs typeface="Calibri" pitchFamily="34" charset="0"/>
+              </a:rPr>
+              <a:t>Outcome</a:t>
+            </a:r>
+          </a:p>
+        </p:txBody>
+      </p:sp>
+      <p:cxnSp>
+        <p:nvCxnSpPr>
+          <p:cNvPr id="29" name="c29"/>
+          <p:cNvCxnSpPr/>
+          <p:nvPr/>
+        </p:nvCxnSpPr>
+        <p:spPr>
+          <a:xfrm>
+            <a:off x="2128752" y="2690000"/>
+            <a:ext cx="120000" cy="1"/>
+          </a:xfrm>
+          <a:prstGeom prst="line">
+            <a:avLst/>
+          </a:prstGeom>
+          <a:ln w="28575" cap="rnd">
+            <a:solidFill>
+              <a:srgbClr val="546E7A"/>
+            </a:solidFill>
+            <a:tailEnd type="triangle" w="med" len="med"/>
+          </a:ln>
+        </p:spPr>
+      </p:cxnSp>
+      <p:cxnSp>
+        <p:nvCxnSpPr>
+          <p:cNvPr id="30" name="c30"/>
+          <p:cNvCxnSpPr/>
+          <p:nvPr/>
+        </p:nvCxnSpPr>
+        <p:spPr>
+          <a:xfrm>
+            <a:off x="4078752" y="2690000"/>
+            <a:ext cx="120000" cy="1"/>
+          </a:xfrm>
+          <a:prstGeom prst="line">
+            <a:avLst/>
+          </a:prstGeom>
+          <a:ln w="28575" cap="rnd">
+            <a:solidFill>
+              <a:srgbClr val="546E7A"/>
+            </a:solidFill>
+            <a:tailEnd type="triangle" w="med" len="med"/>
+          </a:ln>
+        </p:spPr>
+      </p:cxnSp>
+      <p:cxnSp>
+        <p:nvCxnSpPr>
+          <p:cNvPr id="31" name="c31"/>
+          <p:cNvCxnSpPr/>
+          <p:nvPr/>
+        </p:nvCxnSpPr>
+        <p:spPr>
+          <a:xfrm>
+            <a:off x="6028752" y="2690000"/>
+            <a:ext cx="120000" cy="1"/>
+          </a:xfrm>
+          <a:prstGeom prst="line">
+            <a:avLst/>
+          </a:prstGeom>
+          <a:ln w="28575" cap="rnd">
+            <a:solidFill>
+              <a:srgbClr val="546E7A"/>
+            </a:solidFill>
+            <a:tailEnd type="triangle" w="med" len="med"/>
+          </a:ln>
+        </p:spPr>
+      </p:cxnSp>
+      <p:cxnSp>
+        <p:nvCxnSpPr>
+          <p:cNvPr id="32" name="c32"/>
+          <p:cNvCxnSpPr/>
+          <p:nvPr/>
+        </p:nvCxnSpPr>
+        <p:spPr>
+          <a:xfrm>
+            <a:off x="7978752" y="2690000"/>
+            <a:ext cx="120000" cy="1"/>
+          </a:xfrm>
+          <a:prstGeom prst="line">
+            <a:avLst/>
+          </a:prstGeom>
+          <a:ln w="28575" cap="rnd">
+            <a:solidFill>
+              <a:srgbClr val="546E7A"/>
+            </a:solidFill>
+            <a:tailEnd type="triangle" w="med" len="med"/>
+          </a:ln>
+        </p:spPr>
+      </p:cxnSp>
+      <p:cxnSp>
+        <p:nvCxnSpPr>
+          <p:cNvPr id="33" name="c33"/>
+          <p:cNvCxnSpPr/>
+          <p:nvPr/>
+        </p:nvCxnSpPr>
+        <p:spPr>
+          <a:xfrm>
+            <a:off x="9928752" y="2690000"/>
+            <a:ext cx="120000" cy="1"/>
+          </a:xfrm>
+          <a:prstGeom prst="line">
+            <a:avLst/>
+          </a:prstGeom>
+          <a:ln w="28575" cap="rnd">
+            <a:solidFill>
+              <a:srgbClr val="546E7A"/>
+            </a:solidFill>
+            <a:tailEnd type="triangle" w="med" len="med"/>
+          </a:ln>
+        </p:spPr>
+      </p:cxnSp>
+      <p:sp>
+        <p:nvSpPr>
+          <p:cNvPr id="34" name="chr"/>
+          <p:cNvSpPr/>
+          <p:nvPr/>
+        </p:nvSpPr>
+        <p:spPr>
+          <a:xfrm>
+            <a:off x="313752" y="3150000"/>
+            <a:ext cx="11564000" cy="520000"/>
+          </a:xfrm>
+          <a:prstGeom prst="roundRect">
+            <a:avLst>
+              <a:gd name="adj" fmla="val 14000"/>
+            </a:avLst>
+          </a:prstGeom>
+          <a:solidFill>
+            <a:srgbClr val="E3F0FF"/>
+          </a:solidFill>
+          <a:ln>
+            <a:noFill/>
+          </a:ln>
+        </p:spPr>
+        <p:txBody>
+          <a:bodyPr wrap="square" rtlCol="0" anchor="ctr" lIns="91440" rIns="91440" tIns="45720" bIns="45720">
+            <a:normAutofit/>
+          </a:bodyPr>
+          <a:lstStyle/>
+          <a:p>
+            <a:pPr marL="0" indent="0" algn="ctr">
+              <a:buNone/>
+            </a:pPr>
+            <a:r>
+              <a:rPr lang="en-US" sz="1050" b="1" i="0" dirty="0">
+                <a:solidFill>
+                  <a:srgbClr val="1A2B4C"/>
+                </a:solidFill>
+                <a:latin typeface="Calibri" pitchFamily="34" charset="0"/>
+                <a:cs typeface="Calibri" pitchFamily="34" charset="0"/>
+              </a:rPr>
+              <a:t>Agent traits:  Understands objectives  ·  Breaks work into steps  ·  Uses tools &amp; systems  ·  Decides from context  ·  Iteratively improves outcomes</a:t>
+            </a:r>
+          </a:p>
+        </p:txBody>
+      </p:sp>
+      <p:sp>
+        <p:nvSpPr>
+          <p:cNvPr id="35" name="cb"/>
+          <p:cNvSpPr/>
+          <p:nvPr/>
+        </p:nvSpPr>
+        <p:spPr>
+          <a:xfrm>
+            <a:off x="313752" y="3780000"/>
+            <a:ext cx="5650000" cy="2520000"/>
+          </a:xfrm>
+          <a:prstGeom prst="roundRect">
+            <a:avLst>
+              <a:gd name="adj" fmla="val 5000"/>
+            </a:avLst>
+          </a:prstGeom>
+          <a:solidFill>
+            <a:srgbClr val="E0F2F1"/>
+          </a:solidFill>
+          <a:ln>
+            <a:noFill/>
+          </a:ln>
+        </p:spPr>
+        <p:txBody>
+          <a:bodyPr wrap="square" rtlCol="0" anchor="t" lIns="91440" rIns="91440" tIns="45720" bIns="45720">
+            <a:normAutofit/>
+          </a:bodyPr>
+          <a:lstStyle/>
+          <a:p>
+            <a:endParaRPr lang="en-US"/>
+          </a:p>
+        </p:txBody>
+      </p:sp>
+      <p:sp>
+        <p:nvSpPr>
+          <p:cNvPr id="36" name="ch"/>
+          <p:cNvSpPr/>
+          <p:nvPr/>
+        </p:nvSpPr>
+        <p:spPr>
+          <a:xfrm>
+            <a:off x="313752" y="3780000"/>
+            <a:ext cx="5650000" cy="470000"/>
+          </a:xfrm>
+          <a:prstGeom prst="roundRect">
+            <a:avLst>
+              <a:gd name="adj" fmla="val 10000"/>
+            </a:avLst>
+          </a:prstGeom>
+          <a:solidFill>
+            <a:srgbClr val="00897B"/>
+          </a:solidFill>
+          <a:ln>
+            <a:noFill/>
+          </a:ln>
+        </p:spPr>
+        <p:txBody>
+          <a:bodyPr wrap="square" rtlCol="0" anchor="ctr" lIns="91440" rIns="91440" tIns="45720" bIns="45720">
+            <a:normAutofit/>
+          </a:bodyPr>
+          <a:lstStyle/>
+          <a:p>
+            <a:pPr marL="0" indent="0" algn="l">
+              <a:buNone/>
+            </a:pPr>
+            <a:r>
+              <a:rPr lang="en-US" sz="1200" b="1" i="0" dirty="0">
+                <a:solidFill>
+                  <a:srgbClr val="FFFFFF"/>
+                </a:solidFill>
+                <a:latin typeface="Calibri" pitchFamily="34" charset="0"/>
+                <a:cs typeface="Calibri" pitchFamily="34" charset="0"/>
+              </a:rPr>
+              <a:t>🩺  Healthcare — Prior Authorization Review Agent</a:t>
+            </a:r>
+          </a:p>
+        </p:txBody>
+      </p:sp>
+      <p:sp>
+        <p:nvSpPr>
+          <p:cNvPr id="37" name="ct"/>
+          <p:cNvSpPr/>
+          <p:nvPr/>
+        </p:nvSpPr>
+        <p:spPr>
+          <a:xfrm>
+            <a:off x="431752" y="4300000"/>
+            <a:ext cx="5414000" cy="1940000"/>
+          </a:xfrm>
+          <a:prstGeom prst="rect">
+            <a:avLst/>
+          </a:prstGeom>
+          <a:noFill/>
+          <a:ln>
+            <a:noFill/>
+          </a:ln>
+        </p:spPr>
+        <p:txBody>
+          <a:bodyPr wrap="square" rtlCol="0" anchor="t" lIns="91440" rIns="91440" tIns="45720" bIns="45720">
+            <a:normAutofit/>
+          </a:bodyPr>
+          <a:lstStyle/>
+          <a:p>
+            <a:pPr marL="0" indent="0" algn="l">
+              <a:buNone/>
+            </a:pPr>
+            <a:r>
+              <a:rPr lang="en-US" sz="1000" b="0" i="0" dirty="0">
+                <a:solidFill>
+                  <a:srgbClr val="1A2B4C"/>
+                </a:solidFill>
+                <a:latin typeface="Calibri" pitchFamily="34" charset="0"/>
+                <a:cs typeface="Calibri" pitchFamily="34" charset="0"/>
+              </a:rPr>
+              <a:t>1.  Receives authorization request</a:t>
+            </a:r>
+          </a:p>
+          <a:p>
+            <a:pPr marL="0" indent="0" algn="l">
+              <a:spcBef>
+                <a:spcPts val="200"/>
+              </a:spcBef>
+              <a:buNone/>
+            </a:pPr>
+            <a:r>
+              <a:rPr lang="en-US" sz="1000" b="0" i="0" dirty="0">
+                <a:solidFill>
+                  <a:srgbClr val="1A2B4C"/>
+                </a:solidFill>
+                <a:latin typeface="Calibri" pitchFamily="34" charset="0"/>
+                <a:cs typeface="Calibri" pitchFamily="34" charset="0"/>
+              </a:rPr>
+              <a:t>2.  Retrieves CMS / MCG guidelines</a:t>
+            </a:r>
+          </a:p>
+          <a:p>
+            <a:pPr marL="0" indent="0" algn="l">
+              <a:spcBef>
+                <a:spcPts val="200"/>
+              </a:spcBef>
+              <a:buNone/>
+            </a:pPr>
+            <a:r>
+              <a:rPr lang="en-US" sz="1000" b="0" i="0" dirty="0">
+                <a:solidFill>
+                  <a:srgbClr val="1A2B4C"/>
+                </a:solidFill>
+                <a:latin typeface="Calibri" pitchFamily="34" charset="0"/>
+                <a:cs typeface="Calibri" pitchFamily="34" charset="0"/>
+              </a:rPr>
+              <a:t>3.  Reviews clinical documentation</a:t>
+            </a:r>
+          </a:p>
+          <a:p>
+            <a:pPr marL="0" indent="0" algn="l">
+              <a:spcBef>
+                <a:spcPts val="200"/>
+              </a:spcBef>
+              <a:buNone/>
+            </a:pPr>
+            <a:r>
+              <a:rPr lang="en-US" sz="1000" b="0" i="0" dirty="0">
+                <a:solidFill>
+                  <a:srgbClr val="1A2B4C"/>
+                </a:solidFill>
+                <a:latin typeface="Calibri" pitchFamily="34" charset="0"/>
+                <a:cs typeface="Calibri" pitchFamily="34" charset="0"/>
+              </a:rPr>
+              <a:t>4.  Identifies missing information</a:t>
+            </a:r>
+          </a:p>
+          <a:p>
+            <a:pPr marL="0" indent="0" algn="l">
+              <a:spcBef>
+                <a:spcPts val="200"/>
+              </a:spcBef>
+              <a:buNone/>
+            </a:pPr>
+            <a:r>
+              <a:rPr lang="en-US" sz="1000" b="0" i="0" dirty="0">
+                <a:solidFill>
+                  <a:srgbClr val="1A2B4C"/>
+                </a:solidFill>
+                <a:latin typeface="Calibri" pitchFamily="34" charset="0"/>
+                <a:cs typeface="Calibri" pitchFamily="34" charset="0"/>
+              </a:rPr>
+              <a:t>5.  Generates recommendation</a:t>
+            </a:r>
+          </a:p>
+          <a:p>
+            <a:pPr marL="0" indent="0" algn="l">
+              <a:spcBef>
+                <a:spcPts val="200"/>
+              </a:spcBef>
+              <a:buNone/>
+            </a:pPr>
+            <a:r>
+              <a:rPr lang="en-US" sz="1000" b="0" i="0" dirty="0">
+                <a:solidFill>
+                  <a:srgbClr val="1A2B4C"/>
+                </a:solidFill>
+                <a:latin typeface="Calibri" pitchFamily="34" charset="0"/>
+                <a:cs typeface="Calibri" pitchFamily="34" charset="0"/>
+              </a:rPr>
+              <a:t>6.  Creates rationale for reviewer</a:t>
+            </a:r>
+          </a:p>
+          <a:p>
+            <a:pPr marL="0" indent="0" algn="l">
+              <a:spcBef>
+                <a:spcPts val="200"/>
+              </a:spcBef>
+              <a:buNone/>
+            </a:pPr>
+            <a:r>
+              <a:rPr lang="en-US" sz="1000" b="0" i="0" dirty="0">
+                <a:solidFill>
+                  <a:srgbClr val="1A2B4C"/>
+                </a:solidFill>
+                <a:latin typeface="Calibri" pitchFamily="34" charset="0"/>
+                <a:cs typeface="Calibri" pitchFamily="34" charset="0"/>
+              </a:rPr>
+              <a:t>7.  Routes case to nurse or physician</a:t>
+            </a:r>
+          </a:p>
+        </p:txBody>
+      </p:sp>
+      <p:sp>
+        <p:nvSpPr>
+          <p:cNvPr id="38" name="cb"/>
+          <p:cNvSpPr/>
+          <p:nvPr/>
+        </p:nvSpPr>
+        <p:spPr>
+          <a:xfrm>
+            <a:off x="6228248" y="3780000"/>
+            <a:ext cx="5650000" cy="2520000"/>
+          </a:xfrm>
+          <a:prstGeom prst="roundRect">
+            <a:avLst>
+              <a:gd name="adj" fmla="val 5000"/>
+            </a:avLst>
+          </a:prstGeom>
+          <a:solidFill>
+            <a:srgbClr val="EDE7F6"/>
+          </a:solidFill>
+          <a:ln>
+            <a:noFill/>
+          </a:ln>
+        </p:spPr>
+        <p:txBody>
+          <a:bodyPr wrap="square" rtlCol="0" anchor="t" lIns="91440" rIns="91440" tIns="45720" bIns="45720">
+            <a:normAutofit/>
+          </a:bodyPr>
+          <a:lstStyle/>
+          <a:p>
+            <a:endParaRPr lang="en-US"/>
+          </a:p>
+        </p:txBody>
+      </p:sp>
+      <p:sp>
+        <p:nvSpPr>
+          <p:cNvPr id="39" name="ch"/>
+          <p:cNvSpPr/>
+          <p:nvPr/>
+        </p:nvSpPr>
+        <p:spPr>
+          <a:xfrm>
+            <a:off x="6228248" y="3780000"/>
+            <a:ext cx="5650000" cy="470000"/>
+          </a:xfrm>
+          <a:prstGeom prst="roundRect">
+            <a:avLst>
+              <a:gd name="adj" fmla="val 10000"/>
+            </a:avLst>
+          </a:prstGeom>
+          <a:solidFill>
+            <a:srgbClr val="5E35B1"/>
+          </a:solidFill>
+          <a:ln>
+            <a:noFill/>
+          </a:ln>
+        </p:spPr>
+        <p:txBody>
+          <a:bodyPr wrap="square" rtlCol="0" anchor="ctr" lIns="91440" rIns="91440" tIns="45720" bIns="45720">
+            <a:normAutofit/>
+          </a:bodyPr>
+          <a:lstStyle/>
+          <a:p>
+            <a:pPr marL="0" indent="0" algn="l">
+              <a:buNone/>
+            </a:pPr>
+            <a:r>
+              <a:rPr lang="en-US" sz="1200" b="1" i="0" dirty="0">
+                <a:solidFill>
+                  <a:srgbClr val="FFFFFF"/>
+                </a:solidFill>
+                <a:latin typeface="Calibri" pitchFamily="34" charset="0"/>
+                <a:cs typeface="Calibri" pitchFamily="34" charset="0"/>
+              </a:rPr>
+              <a:t>📈  Business — Market Research Agent</a:t>
+            </a:r>
+          </a:p>
+        </p:txBody>
+      </p:sp>
+      <p:sp>
+        <p:nvSpPr>
+          <p:cNvPr id="40" name="ct"/>
+          <p:cNvSpPr/>
+          <p:nvPr/>
+        </p:nvSpPr>
+        <p:spPr>
+          <a:xfrm>
+            <a:off x="6346248" y="4300000"/>
+            <a:ext cx="5414000" cy="1940000"/>
+          </a:xfrm>
+          <a:prstGeom prst="rect">
+            <a:avLst/>
+          </a:prstGeom>
+          <a:noFill/>
+          <a:ln>
+            <a:noFill/>
+          </a:ln>
+        </p:spPr>
+        <p:txBody>
+          <a:bodyPr wrap="square" rtlCol="0" anchor="t" lIns="91440" rIns="91440" tIns="45720" bIns="45720">
+            <a:normAutofit/>
+          </a:bodyPr>
+          <a:lstStyle/>
+          <a:p>
+            <a:pPr marL="0" indent="0" algn="l">
+              <a:buNone/>
+            </a:pPr>
+            <a:r>
+              <a:rPr lang="en-US" sz="1000" b="0" i="0" dirty="0">
+                <a:solidFill>
+                  <a:srgbClr val="1A2B4C"/>
+                </a:solidFill>
+                <a:latin typeface="Calibri" pitchFamily="34" charset="0"/>
+                <a:cs typeface="Calibri" pitchFamily="34" charset="0"/>
+              </a:rPr>
+              <a:t>1.  Collects market &amp; competitor data</a:t>
+            </a:r>
+          </a:p>
+          <a:p>
+            <a:pPr marL="0" indent="0" algn="l">
+              <a:spcBef>
+                <a:spcPts val="200"/>
+              </a:spcBef>
+              <a:buNone/>
+            </a:pPr>
+            <a:r>
+              <a:rPr lang="en-US" sz="1000" b="0" i="0" dirty="0">
+                <a:solidFill>
+                  <a:srgbClr val="1A2B4C"/>
+                </a:solidFill>
+                <a:latin typeface="Calibri" pitchFamily="34" charset="0"/>
+                <a:cs typeface="Calibri" pitchFamily="34" charset="0"/>
+              </a:rPr>
+              <a:t>2.  Analyzes competitors &amp; trends</a:t>
+            </a:r>
+          </a:p>
+          <a:p>
+            <a:pPr marL="0" indent="0" algn="l">
+              <a:spcBef>
+                <a:spcPts val="200"/>
+              </a:spcBef>
+              <a:buNone/>
+            </a:pPr>
+            <a:r>
+              <a:rPr lang="en-US" sz="1000" b="0" i="0" dirty="0">
+                <a:solidFill>
+                  <a:srgbClr val="1A2B4C"/>
+                </a:solidFill>
+                <a:latin typeface="Calibri" pitchFamily="34" charset="0"/>
+                <a:cs typeface="Calibri" pitchFamily="34" charset="0"/>
+              </a:rPr>
+              <a:t>3.  Summarizes key findings</a:t>
+            </a:r>
+          </a:p>
+          <a:p>
+            <a:pPr marL="0" indent="0" algn="l">
+              <a:spcBef>
+                <a:spcPts val="200"/>
+              </a:spcBef>
+              <a:buNone/>
+            </a:pPr>
+            <a:r>
+              <a:rPr lang="en-US" sz="1000" b="0" i="0" dirty="0">
+                <a:solidFill>
+                  <a:srgbClr val="1A2B4C"/>
+                </a:solidFill>
+                <a:latin typeface="Calibri" pitchFamily="34" charset="0"/>
+                <a:cs typeface="Calibri" pitchFamily="34" charset="0"/>
+              </a:rPr>
+              <a:t>4.  Generates executive report</a:t>
+            </a:r>
+          </a:p>
+          <a:p>
+            <a:pPr marL="0" indent="0" algn="l">
+              <a:spcBef>
+                <a:spcPts val="200"/>
+              </a:spcBef>
+              <a:buNone/>
+            </a:pPr>
+            <a:r>
+              <a:rPr lang="en-US" sz="600" b="0" i="0" dirty="0">
+                <a:solidFill>
+                  <a:srgbClr val="1A2B4C"/>
+                </a:solidFill>
+                <a:latin typeface="Calibri" pitchFamily="34" charset="0"/>
+                <a:cs typeface="Calibri" pitchFamily="34" charset="0"/>
+              </a:rPr>
+              <a:t/>
+            </a:r>
+          </a:p>
+          <a:p>
+            <a:pPr marL="0" indent="0" algn="l">
+              <a:spcBef>
+                <a:spcPts val="200"/>
+              </a:spcBef>
+              <a:buNone/>
+            </a:pPr>
+            <a:r>
+              <a:rPr lang="en-US" sz="950" b="0" i="1" dirty="0">
+                <a:solidFill>
+                  <a:srgbClr val="546E7A"/>
+                </a:solidFill>
+                <a:latin typeface="Calibri" pitchFamily="34" charset="0"/>
+                <a:cs typeface="Calibri" pitchFamily="34" charset="0"/>
+              </a:rPr>
+              <a:t>Goal → Plan → Tools → Execute → Validate → Outcome</a:t>
+            </a:r>
+          </a:p>
+        </p:txBody>
+      </p:sp>
+      <p:sp>
+        <p:nvSpPr>
+          <p:cNvPr id="41" name="Footer"/>
+          <p:cNvSpPr/>
+          <p:nvPr/>
+        </p:nvSpPr>
+        <p:spPr>
+          <a:xfrm>
+            <a:off x="182880" y="6413602"/>
+            <a:ext cx="6984187" cy="444398"/>
+          </a:xfrm>
+          <a:prstGeom prst="rect">
+            <a:avLst/>
+          </a:prstGeom>
+          <a:noFill/>
+          <a:ln>
+            <a:noFill/>
+          </a:ln>
+        </p:spPr>
+        <p:txBody>
+          <a:bodyPr wrap="square" rtlCol="0" anchor="ctr" lIns="91440" rIns="91440" tIns="45720" bIns="45720">
+            <a:normAutofit/>
+          </a:bodyPr>
+          <a:lstStyle/>
+          <a:p>
+            <a:pPr marL="0" indent="0" algn="l">
+              <a:buNone/>
+            </a:pPr>
+            <a:r>
+              <a:rPr lang="en-US" sz="700" b="0" i="0" dirty="0">
+                <a:solidFill>
+                  <a:srgbClr val="64748B"/>
+                </a:solidFill>
+                <a:latin typeface="Calibri" pitchFamily="34" charset="0"/>
+                <a:cs typeface="Calibri" pitchFamily="34" charset="0"/>
+              </a:rPr>
+              <a:t>1455 LINCOLN PARKWAY EAST, 8TH FLOOR, ATLANTA, GA 30346 | WWW.INNOVASOLUTIONS.COM</a:t>
+            </a:r>
+          </a:p>
+        </p:txBody>
+      </p:sp>
+      <p:pic>
+        <p:nvPicPr>
+          <p:cNvPr id="42" name="Logo"/>
+          <p:cNvPicPr>
+            <a:picLocks noChangeAspect="1"/>
+          </p:cNvPicPr>
+          <p:nvPr/>
+        </p:nvPicPr>
+        <p:blipFill>
+          <a:blip r:embed="rId2"/>
+          <a:stretch>
+            <a:fillRect/>
+          </a:stretch>
+        </p:blipFill>
+        <p:spPr>
+          <a:xfrm>
+            <a:off x="9960940" y="103430"/>
+            <a:ext cx="2040941" cy="769925"/>
+          </a:xfrm>
+          <a:prstGeom prst="rect">
+            <a:avLst/>
+          </a:prstGeom>
+        </p:spPr>
+      </p:pic>
+    </p:spTree>
+  </p:cSld>
+  <p:clrMapOvr>
+    <a:masterClrMapping/>
+  </p:clrMapOvr>
+</p:sld>
+</file>
+
 <file path=ppt/slides/slide2.xml><?xml version="1.0" encoding="utf-8"?>
 <p:sld xmlns:a="http://schemas.openxmlformats.org/drawingml/2006/main" xmlns:r="http://schemas.openxmlformats.org/officeDocument/2006/relationships" xmlns:p="http://schemas.openxmlformats.org/presentationml/2006/main">
   <p:cSld name="Slide 6">

</xml_diff>